<commit_message>
docs: refresh executive summary (MD + PDF + PPTX) with legal taxonomy and x402
- solution: '+ Grounded in law' (7 categories, official sources across all 22
  jurisdictions, inline citation by legal tradition — BGB §177 / UCC §2-711)
  and '+ x402 on-rail' (402 -> signed X-PAYMENT -> receipt; replay-safe,
  consent-capped on-chain).
- architecture: resolution layer now 'law-cited disputes'; rails include x402.
- proof: 25 endpoints, 49 endpoint tests, 584 green across the project.
- stats callouts on the slide: 22 jurisdictions / 25 endpoints / 7 legal
  categories / 584 tests.
- not-legal-advice disclaimer added to all three artifacts.
Both renders visually QA'd (PDF one page; slide no overflow).
</commit_message>
<xml_diff>
--- a/docs/tvist/Tvist-Executive-Summary.pptx
+++ b/docs/tvist/Tvist-Executive-Summary.pptx
@@ -1092,7 +1092,7 @@
                 <a:ea typeface="Calibri" pitchFamily="34" charset="-122"/>
                 <a:cs typeface="Calibri" pitchFamily="34" charset="-120"/>
               </a:rPr>
-              <a:t>4</a:t>
+              <a:t>25</a:t>
             </a:r>
             <a:endParaRPr lang="en-US" sz="2400" dirty="0"/>
           </a:p>
@@ -1131,7 +1131,7 @@
                 <a:ea typeface="Calibri" pitchFamily="34" charset="-122"/>
                 <a:cs typeface="Calibri" pitchFamily="34" charset="-120"/>
               </a:rPr>
-              <a:t>gates</a:t>
+              <a:t>live endpoints</a:t>
             </a:r>
             <a:endParaRPr lang="en-US" sz="850" dirty="0"/>
           </a:p>
@@ -1170,7 +1170,7 @@
                 <a:ea typeface="Calibri" pitchFamily="34" charset="-122"/>
                 <a:cs typeface="Calibri" pitchFamily="34" charset="-120"/>
               </a:rPr>
-              <a:t>10</a:t>
+              <a:t>7</a:t>
             </a:r>
             <a:endParaRPr lang="en-US" sz="2400" dirty="0"/>
           </a:p>
@@ -1209,7 +1209,7 @@
                 <a:ea typeface="Calibri" pitchFamily="34" charset="-122"/>
                 <a:cs typeface="Calibri" pitchFamily="34" charset="-120"/>
               </a:rPr>
-              <a:t>adv. validators</a:t>
+              <a:t>legal categories</a:t>
             </a:r>
             <a:endParaRPr lang="en-US" sz="850" dirty="0"/>
           </a:p>
@@ -1248,7 +1248,7 @@
                 <a:ea typeface="Calibri" pitchFamily="34" charset="-122"/>
                 <a:cs typeface="Calibri" pitchFamily="34" charset="-120"/>
               </a:rPr>
-              <a:t>574</a:t>
+              <a:t>584</a:t>
             </a:r>
             <a:endParaRPr lang="en-US" sz="2400" dirty="0"/>
           </a:p>
@@ -2472,24 +2472,44 @@
         </p:nvSpPr>
         <p:spPr>
           <a:xfrm>
-            <a:off x="4800600" y="6035040"/>
-            <a:ext cx="3520440" cy="320040"/>
-          </a:xfrm>
-          <a:prstGeom prst="rect">
-            <a:avLst/>
-          </a:prstGeom>
-          <a:noFill/>
-          <a:ln/>
-        </p:spPr>
-        <p:txBody>
-          <a:bodyPr wrap="square" rtlCol="0" anchor="ctr"/>
+            <a:off x="4800600" y="5989320"/>
+            <a:ext cx="3520440" cy="640080"/>
+          </a:xfrm>
+          <a:prstGeom prst="rect">
+            <a:avLst/>
+          </a:prstGeom>
+          <a:noFill/>
+          <a:ln/>
+        </p:spPr>
+        <p:txBody>
+          <a:bodyPr wrap="square" rtlCol="0" anchor="t"/>
           <a:lstStyle/>
           <a:p>
             <a:pPr indent="0" marL="0">
-              <a:buNone/>
-            </a:pPr>
-            <a:r>
-              <a:rPr lang="en-US" sz="950" i="1" dirty="0">
+              <a:lnSpc>
+                <a:spcPct val="100000"/>
+              </a:lnSpc>
+              <a:buNone/>
+            </a:pPr>
+            <a:r>
+              <a:rPr lang="en-US" sz="860" b="1" dirty="0">
+                <a:solidFill>
+                  <a:srgbClr val="2DD4BF"/>
+                </a:solidFill>
+                <a:latin typeface="Calibri" pitchFamily="34" charset="0"/>
+                <a:ea typeface="Calibri" pitchFamily="34" charset="-122"/>
+                <a:cs typeface="Calibri" pitchFamily="34" charset="-120"/>
+              </a:rPr>
+              <a:t>+ Grounded in law: </a:t>
+            </a:r>
+            <a:pPr indent="0" marL="0">
+              <a:lnSpc>
+                <a:spcPct val="100000"/>
+              </a:lnSpc>
+              <a:buNone/>
+            </a:pPr>
+            <a:r>
+              <a:rPr lang="en-US" sz="860" dirty="0">
                 <a:solidFill>
                   <a:srgbClr val="93A0C4"/>
                 </a:solidFill>
@@ -2497,9 +2517,43 @@
                 <a:ea typeface="Calibri" pitchFamily="34" charset="-122"/>
                 <a:cs typeface="Calibri" pitchFamily="34" charset="-120"/>
               </a:rPr>
-              <a:t>Thin orchestration layer — not a bank; regulated custody partners hold funds.</a:t>
-            </a:r>
-            <a:endParaRPr lang="en-US" sz="950" dirty="0"/>
+              <a:t>accepted disputes return the citation inline (BGB §177 · UCC §2-711).  </a:t>
+            </a:r>
+            <a:pPr indent="0" marL="0">
+              <a:lnSpc>
+                <a:spcPct val="100000"/>
+              </a:lnSpc>
+              <a:buNone/>
+            </a:pPr>
+            <a:r>
+              <a:rPr lang="en-US" sz="860" b="1" dirty="0">
+                <a:solidFill>
+                  <a:srgbClr val="2DD4BF"/>
+                </a:solidFill>
+                <a:latin typeface="Calibri" pitchFamily="34" charset="0"/>
+                <a:ea typeface="Calibri" pitchFamily="34" charset="-122"/>
+                <a:cs typeface="Calibri" pitchFamily="34" charset="-120"/>
+              </a:rPr>
+              <a:t>+ x402 on-rail: </a:t>
+            </a:r>
+            <a:pPr indent="0" marL="0">
+              <a:lnSpc>
+                <a:spcPct val="100000"/>
+              </a:lnSpc>
+              <a:buNone/>
+            </a:pPr>
+            <a:r>
+              <a:rPr lang="en-US" sz="860" dirty="0">
+                <a:solidFill>
+                  <a:srgbClr val="93A0C4"/>
+                </a:solidFill>
+                <a:latin typeface="Calibri" pitchFamily="34" charset="0"/>
+                <a:ea typeface="Calibri" pitchFamily="34" charset="-122"/>
+                <a:cs typeface="Calibri" pitchFamily="34" charset="-120"/>
+              </a:rPr>
+              <a:t>402 → signed X-PAYMENT → receipt; replay-safe, consent-capped.</a:t>
+            </a:r>
+            <a:endParaRPr lang="en-US" sz="860" dirty="0"/>
           </a:p>
         </p:txBody>
       </p:sp>
@@ -3104,7 +3158,7 @@
                 <a:ea typeface="Calibri" pitchFamily="34" charset="-122"/>
                 <a:cs typeface="Calibri" pitchFamily="34" charset="-120"/>
               </a:rPr>
-              <a:t>regime-gated recall · disputes</a:t>
+              <a:t>recall · law-cited disputes</a:t>
             </a:r>
             <a:endParaRPr lang="en-US" sz="900" dirty="0"/>
           </a:p>
@@ -3184,7 +3238,7 @@
                 <a:ea typeface="Calibri" pitchFamily="34" charset="-122"/>
                 <a:cs typeface="Calibri" pitchFamily="34" charset="-120"/>
               </a:rPr>
-              <a:t>Pix · SEPA · FedNow · UPI · M-Pesa …</a:t>
+              <a:t>Pix · SEPA · UPI · x402 …</a:t>
             </a:r>
             <a:endParaRPr lang="en-US" sz="900" dirty="0"/>
           </a:p>
@@ -3309,7 +3363,7 @@
                 <a:ea typeface="Calibri" pitchFamily="34" charset="-122"/>
                 <a:cs typeface="Calibri" pitchFamily="34" charset="-120"/>
               </a:rPr>
-              <a:t>Live dual-use API + site; agents integrate from one SKILL.md. DigiDoot (an agent per Indian citizen) as flagship use case.</a:t>
+              <a:t>Live dual-use API + site: 25 endpoints incl. legal taxonomy + native x402; 584 tests green. DigiDoot as flagship use case.</a:t>
             </a:r>
             <a:endParaRPr lang="en-US" sz="880" dirty="0"/>
           </a:p>
@@ -3362,7 +3416,21 @@
                 <a:ea typeface="Calibri" pitchFamily="34" charset="-122"/>
                 <a:cs typeface="Calibri" pitchFamily="34" charset="-120"/>
               </a:rPr>
-              <a:t>Complementary, not competitive — networks get their intent standards operationalized; custody providers get their rules engine; agent platforms get the trust layer their checkout protocols defer. The wedge compounds with every rail, protocol, and jurisdiction added.</a:t>
+              <a:t>Complementary, not competitive — networks get their intent standards operationalized; custody providers their rules engine; agent platforms the trust layer their protocols defer.  </a:t>
+            </a:r>
+            <a:pPr algn="l" indent="0" marL="0">
+              <a:buNone/>
+            </a:pPr>
+            <a:r>
+              <a:rPr lang="en-US" sz="950" i="1" dirty="0">
+                <a:solidFill>
+                  <a:srgbClr val="93A0C4"/>
+                </a:solidFill>
+                <a:latin typeface="Calibri" pitchFamily="34" charset="0"/>
+                <a:ea typeface="Calibri" pitchFamily="34" charset="-122"/>
+                <a:cs typeface="Calibri" pitchFamily="34" charset="-120"/>
+              </a:rPr>
+              <a:t>Technical demo — notional credits, not a bank; legal citations are not legal advice.</a:t>
             </a:r>
             <a:endParaRPr lang="en-US" sz="950" dirty="0"/>
           </a:p>

</xml_diff>

<commit_message>
tvist: sync SKILL.md + all four executive artifacts with current service
Regenerated brief PDF, summary PDF, DOCX, and deck PPTX with verified
figures: 33 endpoints, 61 service tests, 586 rig tests, 647 green
project-wide; added the new site functionality (executive-summary
teaser, jurisdiction globe with live legal clauses, Nash 1-1/1-n/n-n
visualizer, GET /regions/suggest suggested start) to the summary
documents, EXECUTIVE-SUMMARY.md, and SKILL.md's dual-use note.
Artifact contents verified via pdftotext / unzip before shipping.
</commit_message>
<xml_diff>
--- a/docs/tvist/Tvist-Executive-Summary.pptx
+++ b/docs/tvist/Tvist-Executive-Summary.pptx
@@ -1537,7 +1537,7 @@
                 <a:ea typeface="Calibri" pitchFamily="34" charset="-122"/>
                 <a:cs typeface="Calibri" pitchFamily="34" charset="-120"/>
               </a:rPr>
-              <a:t>30</a:t>
+              <a:t>33</a:t>
             </a:r>
             <a:endParaRPr lang="en-US" sz="2400" dirty="0"/>
           </a:p>
@@ -1693,7 +1693,7 @@
                 <a:ea typeface="Calibri" pitchFamily="34" charset="-122"/>
                 <a:cs typeface="Calibri" pitchFamily="34" charset="-120"/>
               </a:rPr>
-              <a:t>595</a:t>
+              <a:t>647</a:t>
             </a:r>
             <a:endParaRPr lang="en-US" sz="2400" dirty="0"/>
           </a:p>
@@ -3842,7 +3842,7 @@
                 <a:ea typeface="Calibri" pitchFamily="34" charset="-122"/>
                 <a:cs typeface="Calibri" pitchFamily="34" charset="-120"/>
               </a:rPr>
-              <a:t>Live dual-use API + site: 30 endpoints incl. legal taxonomy, x402, M2M + spectrum; 595 tests green. DigiDoot as flagship use case.</a:t>
+              <a:t>Live dual-use API + site: 33 endpoints incl. legal taxonomy, x402, M2M, region-suggest + spectrum; jurisdiction globe + Nash 1–1/1–n/n–n visualizer; 647 tests green. DigiDoot as flagship use case.</a:t>
             </a:r>
             <a:endParaRPr lang="en-US" sz="880" dirty="0"/>
           </a:p>
@@ -16578,7 +16578,7 @@
                 <a:ea typeface="Calibri" pitchFamily="34" charset="-122"/>
                 <a:cs typeface="Calibri" pitchFamily="34" charset="-120"/>
               </a:rPr>
-              <a:t>4 swarm scenarios, 10 adversarial validators — every attack blocked vs a plain ledger; 539 tests.
+              <a:t>4 swarm scenarios, 10 adversarial validators — every attack blocked vs a plain ledger; 586 tests.
 </a:t>
             </a:r>
             <a:pPr indent="0" marL="0">
@@ -16613,7 +16613,7 @@
                 <a:ea typeface="Calibri" pitchFamily="34" charset="-122"/>
                 <a:cs typeface="Calibri" pitchFamily="34" charset="-120"/>
               </a:rPr>
-              <a:t>30 endpoints, one SKILL.md, 56 endpoint tests — 595 green total.
+              <a:t>33 endpoints incl. region-suggest, jurisdiction globe + Nash visualizer on-site, one SKILL.md, 61 endpoint tests — 647 green total.
 </a:t>
             </a:r>
             <a:pPr indent="0" marL="0">

</xml_diff>

<commit_message>
artifacts: rebrand to tvist.api, add live URL, regenerate PDFs
- Brief + summary PDFs regenerated from new committed generators
  (tools/make_brief_pdf.py, make_summary_pdf.py — the old scratchpad
  generators were lost): tvist.api brand, current verified figures
  (33 endpoints, 61/586/647 tests, 41/41 live sweep), live Vercel URL,
  sources, disclaimer.
- DOCX + PPTX patched in place (XML text runs): brand .ai -> .api and
  the live URL added to the overview/proof slides and before the DOCX
  disclaimer; well-formedness verified.
- EXECUTIVE-SUMMARY.md: same rebrand + live link.
</commit_message>
<xml_diff>
--- a/docs/tvist/Tvist-Executive-Summary.pptx
+++ b/docs/tvist/Tvist-Executive-Summary.pptx
@@ -1367,7 +1367,7 @@
                 <a:ea typeface="Calibri" pitchFamily="34" charset="-122"/>
                 <a:cs typeface="Calibri" pitchFamily="34" charset="-120"/>
               </a:rPr>
-              <a:t>.ai</a:t>
+              <a:t>.api</a:t>
             </a:r>
             <a:pPr algn="l" indent="0" marL="0">
               <a:buNone/>
@@ -3842,7 +3842,7 @@
                 <a:ea typeface="Calibri" pitchFamily="34" charset="-122"/>
                 <a:cs typeface="Calibri" pitchFamily="34" charset="-120"/>
               </a:rPr>
-              <a:t>Live dual-use API + site: 33 endpoints incl. legal taxonomy, x402, M2M, region-suggest + spectrum; jurisdiction globe + Nash 1–1/1–n/n–n visualizer; 647 tests green. DigiDoot as flagship use case.</a:t>
+              <a:t>Live dual-use API + site: 33 endpoints incl. legal taxonomy, x402, M2M, region-suggest + spectrum; jurisdiction globe + Nash 1–1/1–n/n–n visualizer; 647 tests green. DigiDoot as flagship use case. Live: tvist-api-mias-projects-667d1349.vercel.app</a:t>
             </a:r>
             <a:endParaRPr lang="en-US" sz="880" dirty="0"/>
           </a:p>
@@ -16613,7 +16613,7 @@
                 <a:ea typeface="Calibri" pitchFamily="34" charset="-122"/>
                 <a:cs typeface="Calibri" pitchFamily="34" charset="-120"/>
               </a:rPr>
-              <a:t>33 endpoints incl. region-suggest, jurisdiction globe + Nash visualizer on-site, one SKILL.md, 61 endpoint tests — 647 green total.
+              <a:t>33 endpoints incl. region-suggest, jurisdiction globe + Nash visualizer on-site, one SKILL.md, 61 endpoint tests — 647 green total. Live: tvist-api-mias-projects-667d1349.vercel.app
 </a:t>
             </a:r>
             <a:pPr indent="0" marL="0">

</xml_diff>